<commit_message>
Registration opens November 15
Co-Authored-By: Claude Opus 5.5 <noreply@anthropic.com>
</commit_message>
<xml_diff>
--- a/docs/KDO-Proposal.pptx
+++ b/docs/KDO-Proposal.pptx
@@ -9472,7 +9472,7 @@
                 <a:ea typeface="DM Serif Text" pitchFamily="34" charset="-122"/>
                 <a:cs typeface="DM Serif Text" pitchFamily="34" charset="-120"/>
               </a:rPr>
-              <a:t>Nov</a:t>
+              <a:t>Nov 8</a:t>
             </a:r>
             <a:endParaRPr lang="en-US" sz="2200" dirty="0"/>
           </a:p>
@@ -9511,7 +9511,7 @@
                 <a:ea typeface="DM Sans" pitchFamily="34" charset="-122"/>
                 <a:cs typeface="DM Sans" pitchFamily="34" charset="-120"/>
               </a:rPr>
-              <a:t>State letter, fire marshal, insurance quote</a:t>
+              <a:t>Announce at church; hiring starts</a:t>
             </a:r>
             <a:endParaRPr lang="en-US" sz="1500" dirty="0"/>
           </a:p>
@@ -9575,7 +9575,7 @@
                 <a:ea typeface="DM Serif Text" pitchFamily="34" charset="-122"/>
                 <a:cs typeface="DM Serif Text" pitchFamily="34" charset="-120"/>
               </a:rPr>
-              <a:t>Nov</a:t>
+              <a:t>Nov 15</a:t>
             </a:r>
             <a:endParaRPr lang="en-US" sz="2200" dirty="0"/>
           </a:p>
@@ -9614,7 +9614,7 @@
                 <a:ea typeface="DM Sans" pitchFamily="34" charset="-122"/>
                 <a:cs typeface="DM Sans" pitchFamily="34" charset="-120"/>
               </a:rPr>
-              <a:t>Hiring starts: teachers and subs</a:t>
+              <a:t>Registration opens</a:t>
             </a:r>
             <a:endParaRPr lang="en-US" sz="1500" dirty="0"/>
           </a:p>
@@ -9717,7 +9717,7 @@
                 <a:ea typeface="DM Sans" pitchFamily="34" charset="-122"/>
                 <a:cs typeface="DM Sans" pitchFamily="34" charset="-120"/>
               </a:rPr>
-              <a:t>Teachers and subs hired; registration opens</a:t>
+              <a:t>Teachers and subs hired</a:t>
             </a:r>
             <a:endParaRPr lang="en-US" sz="1500" dirty="0"/>
           </a:p>
@@ -9820,7 +9820,7 @@
                 <a:ea typeface="DM Sans" pitchFamily="34" charset="-122"/>
                 <a:cs typeface="DM Sans" pitchFamily="34" charset="-120"/>
               </a:rPr>
-              <a:t>Training and CPR</a:t>
+              <a:t>Training, CPR, fire marshal</a:t>
             </a:r>
             <a:endParaRPr lang="en-US" sz="1500" dirty="0"/>
           </a:p>

</xml_diff>

<commit_message>
Snacks and supplies fee back to $60, shown per semester
Co-Authored-By: Claude Opus 5.5 <noreply@anthropic.com>
</commit_message>
<xml_diff>
--- a/docs/KDO-Proposal.pptx
+++ b/docs/KDO-Proposal.pptx
@@ -691,7 +691,7 @@
           <a:p>
             <a:r>
               <a:rPr lang="en-US" dirty="0"/>
-              <a:t>This is the long-term plan. We start low on purpose. This first semester is not about making money; at thirty kids it just covers its costs, and if things go slowly our donor covers the gap, so the church is never out anything. Then each semester we add one room, and new families pay twenty five a day, thirty for babies. That is as high as our prices go. The original families keep their founding price the whole time their child is enrolled. With modest growth, KDO is about eight thousand dollars ahead after three semesters.</a:t>
+              <a:t>This is the long-term plan. We start low on purpose. This first semester is not about making money; at thirty kids it just covers its costs, and if things go slowly our donor covers the gap, so the church is never out anything. Then each semester we add one room, and new families pay twenty five a day, thirty for babies. That is as high as our prices go. The original families keep their founding price the whole time their child is enrolled. With modest growth, KDO is about seventy five hundred dollars ahead after three semesters.</a:t>
             </a:r>
             <a:endParaRPr lang="en-US" dirty="0"/>
           </a:p>
@@ -1571,7 +1571,7 @@
           <a:p>
             <a:r>
               <a:rPr lang="en-US" dirty="0"/>
-              <a:t>Tuition is the daily rate times 18 Thursdays. Toddlers and preschoolers are twenty dollars a Thursday and babies are twenty five, since babies need more teachers per child. Families pay monthly, by the seventh. Each payment covers four Thursdays plus thirteen dollars for snacks, wipes, and craft materials, so a toddler is ninety three dollars a month and a baby is a hundred thirteen. May has only two Thursdays, so it is about half. Or they can pay in full and save ten percent. These Founding Family rates stay the same while a child is enrolled; families who join next semester pay twenty five a day, thirty for babies.</a:t>
+              <a:t>Tuition is the daily rate times 18 Thursdays. Toddlers and preschoolers are twenty dollars a Thursday and babies are twenty five, since babies need more teachers per child. Families pay monthly, by the seventh. There is a sixty dollar snacks and supplies fee per child for the semester, for snacks, wipes, and craft materials, spread over the monthly payments. Each payment covers four Thursdays plus twelve dollars of that fee, so a toddler is ninety two dollars a month and a baby is a hundred twelve. May has only two Thursdays, so it is about half. Or they can pay in full and save ten percent. These Founding Family rates stay the same while a child is enrolled; families who join next semester pay twenty five a day, thirty for babies.</a:t>
             </a:r>
             <a:endParaRPr lang="en-US" dirty="0"/>
           </a:p>
@@ -1659,7 +1659,7 @@
           <a:p>
             <a:r>
               <a:rPr lang="en-US" dirty="0"/>
-              <a:t>The bottom line: there is no risk to the church. Green is what comes in, red is what goes out. At twenty dollars a day, twenty five for babies, a full first semester of thirty kids pays for itself. If enrollment comes in low, our donor covers the difference, so the church is not out anything: about thirty two hundred with twelve kids, and about eight hundred with eighteen. We are capping this first semester at 30. New families who join later pay a little more, and that is how KDO grows.</a:t>
+              <a:t>The bottom line: there is no risk to the church. Green is what comes in, red is what goes out. At twenty dollars a day, twenty five for babies, a full first semester of thirty kids pays for itself. If enrollment comes in low, our donor covers the difference, so the church is not out anything: about thirty two hundred with twelve kids, and about nine hundred with eighteen. We are capping this first semester at 30. New families who join later pay a little more, and that is how KDO grows.</a:t>
             </a:r>
             <a:endParaRPr lang="en-US" dirty="0"/>
           </a:p>
@@ -3383,7 +3383,7 @@
                           <a:ea typeface="DM Sans" pitchFamily="34" charset="-122"/>
                           <a:cs typeface="DM Sans" pitchFamily="34" charset="-120"/>
                         </a:rPr>
-                        <a:t>Snacks and supplies fee ($65 per child)</a:t>
+                        <a:t>Snacks and supplies fee ($60 per child)</a:t>
                       </a:r>
                       <a:endParaRPr lang="en-US" sz="1500" dirty="0">
                         <a:latin typeface="DM Sans" charset="0"/>
@@ -3451,7 +3451,7 @@
                           <a:ea typeface="DM Sans" pitchFamily="34" charset="-122"/>
                           <a:cs typeface="DM Sans" pitchFamily="34" charset="-120"/>
                         </a:rPr>
-                        <a:t>$780</a:t>
+                        <a:t>$720</a:t>
                       </a:r>
                       <a:endParaRPr lang="en-US" sz="1500" dirty="0">
                         <a:latin typeface="DM Sans" charset="0"/>
@@ -3519,7 +3519,7 @@
                           <a:ea typeface="DM Sans" pitchFamily="34" charset="-122"/>
                           <a:cs typeface="DM Sans" pitchFamily="34" charset="-120"/>
                         </a:rPr>
-                        <a:t>$1,170</a:t>
+                        <a:t>$1,080</a:t>
                       </a:r>
                       <a:endParaRPr lang="en-US" sz="1500" dirty="0">
                         <a:latin typeface="DM Sans" charset="0"/>
@@ -3587,7 +3587,7 @@
                           <a:ea typeface="DM Sans" pitchFamily="34" charset="-122"/>
                           <a:cs typeface="DM Sans" pitchFamily="34" charset="-120"/>
                         </a:rPr>
-                        <a:t>$1,950</a:t>
+                        <a:t>$1,800</a:t>
                       </a:r>
                       <a:endParaRPr lang="en-US" sz="1500" dirty="0">
                         <a:latin typeface="DM Sans" charset="0"/>
@@ -3725,7 +3725,7 @@
                           <a:ea typeface="DM Sans" pitchFamily="34" charset="-122"/>
                           <a:cs typeface="DM Sans" pitchFamily="34" charset="-120"/>
                         </a:rPr>
-                        <a:t>$3,158</a:t>
+                        <a:t>$3,218</a:t>
                       </a:r>
                       <a:endParaRPr lang="en-US" sz="1500" dirty="0">
                         <a:latin typeface="DM Sans" charset="0"/>
@@ -3793,7 +3793,7 @@
                           <a:ea typeface="DM Sans" pitchFamily="34" charset="-122"/>
                           <a:cs typeface="DM Sans" pitchFamily="34" charset="-120"/>
                         </a:rPr>
-                        <a:t>$842</a:t>
+                        <a:t>$932</a:t>
                       </a:r>
                       <a:endParaRPr lang="en-US" sz="1500" dirty="0">
                         <a:latin typeface="DM Sans" charset="0"/>
@@ -4135,7 +4135,7 @@
                           <a:ea typeface="DM Sans" pitchFamily="34" charset="-122"/>
                           <a:cs typeface="DM Sans" pitchFamily="34" charset="-120"/>
                         </a:rPr>
-                        <a:t>$12,156</a:t>
+                        <a:t>$12,006</a:t>
                       </a:r>
                       <a:endParaRPr lang="en-US" sz="1500" dirty="0">
                         <a:latin typeface="DM Sans" charset="0"/>
@@ -5779,7 +5779,7 @@
                           <a:ea typeface="DM Sans" pitchFamily="34" charset="-122"/>
                           <a:cs typeface="DM Sans" pitchFamily="34" charset="-120"/>
                         </a:rPr>
-                        <a:t>+$444</a:t>
+                        <a:t>+$294</a:t>
                       </a:r>
                       <a:endParaRPr lang="en-US" sz="1800" dirty="0">
                         <a:latin typeface="DM Sans" charset="0"/>
@@ -7257,7 +7257,7 @@
                           <a:ea typeface="DM Sans" pitchFamily="34" charset="-122"/>
                           <a:cs typeface="DM Sans" pitchFamily="34" charset="-120"/>
                         </a:rPr>
-                        <a:t>$12,156</a:t>
+                        <a:t>$12,006</a:t>
                       </a:r>
                       <a:endParaRPr lang="en-US" sz="1600" dirty="0">
                         <a:latin typeface="DM Sans" charset="0"/>
@@ -7325,7 +7325,7 @@
                           <a:ea typeface="DM Sans" pitchFamily="34" charset="-122"/>
                           <a:cs typeface="DM Sans" pitchFamily="34" charset="-120"/>
                         </a:rPr>
-                        <a:t>$17,796</a:t>
+                        <a:t>$17,586</a:t>
                       </a:r>
                       <a:endParaRPr lang="en-US" sz="1600" dirty="0">
                         <a:latin typeface="DM Sans" charset="0"/>
@@ -7393,7 +7393,7 @@
                           <a:ea typeface="DM Sans" pitchFamily="34" charset="-122"/>
                           <a:cs typeface="DM Sans" pitchFamily="34" charset="-120"/>
                         </a:rPr>
-                        <a:t>$23,436</a:t>
+                        <a:t>$23,166</a:t>
                       </a:r>
                       <a:endParaRPr lang="en-US" sz="1600" dirty="0">
                         <a:latin typeface="DM Sans" charset="0"/>
@@ -7805,7 +7805,7 @@
                           <a:ea typeface="DM Sans" pitchFamily="34" charset="-122"/>
                           <a:cs typeface="DM Sans" pitchFamily="34" charset="-120"/>
                         </a:rPr>
-                        <a:t>+$444</a:t>
+                        <a:t>+$294</a:t>
                       </a:r>
                       <a:endParaRPr lang="en-US" sz="2000" dirty="0">
                         <a:latin typeface="DM Sans" charset="0"/>
@@ -7873,7 +7873,7 @@
                           <a:ea typeface="DM Sans" pitchFamily="34" charset="-122"/>
                           <a:cs typeface="DM Sans" pitchFamily="34" charset="-120"/>
                         </a:rPr>
-                        <a:t>+$2,701</a:t>
+                        <a:t>+$2,491</a:t>
                       </a:r>
                       <a:endParaRPr lang="en-US" sz="2000" dirty="0">
                         <a:latin typeface="DM Sans" charset="0"/>
@@ -7941,7 +7941,7 @@
                           <a:ea typeface="DM Sans" pitchFamily="34" charset="-122"/>
                           <a:cs typeface="DM Sans" pitchFamily="34" charset="-120"/>
                         </a:rPr>
-                        <a:t>+$4,958</a:t>
+                        <a:t>+$4,688</a:t>
                       </a:r>
                       <a:endParaRPr lang="en-US" sz="2000" dirty="0">
                         <a:latin typeface="DM Sans" charset="0"/>
@@ -8079,7 +8079,7 @@
                           <a:ea typeface="DM Sans" pitchFamily="34" charset="-122"/>
                           <a:cs typeface="DM Sans" pitchFamily="34" charset="-120"/>
                         </a:rPr>
-                        <a:t>+$444</a:t>
+                        <a:t>+$294</a:t>
                       </a:r>
                       <a:endParaRPr lang="en-US" sz="1600" dirty="0">
                         <a:latin typeface="DM Sans" charset="0"/>
@@ -8147,7 +8147,7 @@
                           <a:ea typeface="DM Sans" pitchFamily="34" charset="-122"/>
                           <a:cs typeface="DM Sans" pitchFamily="34" charset="-120"/>
                         </a:rPr>
-                        <a:t>+$3,145</a:t>
+                        <a:t>+$2,785</a:t>
                       </a:r>
                       <a:endParaRPr lang="en-US" sz="1600" dirty="0">
                         <a:latin typeface="DM Sans" charset="0"/>
@@ -8215,7 +8215,7 @@
                           <a:ea typeface="DM Sans" pitchFamily="34" charset="-122"/>
                           <a:cs typeface="DM Sans" pitchFamily="34" charset="-120"/>
                         </a:rPr>
-                        <a:t>+$8,103</a:t>
+                        <a:t>+$7,473</a:t>
                       </a:r>
                       <a:endParaRPr lang="en-US" sz="1600" dirty="0">
                         <a:latin typeface="DM Sans" charset="0"/>
@@ -16424,7 +16424,7 @@
                 <a:ea typeface="DM Sans" pitchFamily="34" charset="-122"/>
                 <a:cs typeface="DM Sans" pitchFamily="34" charset="-120"/>
               </a:rPr>
-              <a:t>$93 a month, snacks included</a:t>
+              <a:t>$92 a month, snacks included</a:t>
             </a:r>
             <a:endParaRPr lang="en-US" sz="1500" dirty="0"/>
           </a:p>
@@ -16607,7 +16607,7 @@
                 <a:ea typeface="DM Sans" pitchFamily="34" charset="-122"/>
                 <a:cs typeface="DM Sans" pitchFamily="34" charset="-120"/>
               </a:rPr>
-              <a:t>$113 a month, snacks included</a:t>
+              <a:t>$112 a month, snacks included</a:t>
             </a:r>
             <a:endParaRPr lang="en-US" sz="1500" dirty="0"/>
           </a:p>
@@ -16712,7 +16712,7 @@
                 <a:ea typeface="DM Serif Text" pitchFamily="34" charset="-122"/>
                 <a:cs typeface="DM Serif Text" pitchFamily="34" charset="-120"/>
               </a:rPr>
-              <a:t>$13</a:t>
+              <a:t>$60</a:t>
             </a:r>
             <a:endParaRPr lang="en-US" sz="6000" dirty="0"/>
           </a:p>
@@ -16751,7 +16751,7 @@
                 <a:ea typeface="DM Sans" pitchFamily="34" charset="-122"/>
                 <a:cs typeface="DM Sans" pitchFamily="34" charset="-120"/>
               </a:rPr>
-              <a:t>a month, per child</a:t>
+              <a:t>per child, per semester</a:t>
             </a:r>
             <a:endParaRPr lang="en-US" sz="1600" dirty="0"/>
           </a:p>
@@ -16790,7 +16790,7 @@
                 <a:ea typeface="DM Sans" pitchFamily="34" charset="-122"/>
                 <a:cs typeface="DM Sans" pitchFamily="34" charset="-120"/>
               </a:rPr>
-              <a:t>Snacks, wipes, craft materials</a:t>
+              <a:t>Spread over the monthly payments</a:t>
             </a:r>
             <a:endParaRPr lang="en-US" sz="1500" dirty="0"/>
           </a:p>
@@ -17134,7 +17134,7 @@
         <p:spPr>
           <a:xfrm>
             <a:off x="3246120" y="2587752"/>
-            <a:ext cx="2102849" cy="384048"/>
+            <a:ext cx="2103531" cy="384048"/>
           </a:xfrm>
           <a:prstGeom prst="rect">
             <a:avLst/>
@@ -17183,7 +17183,7 @@
                 <a:ea typeface="DM Sans" pitchFamily="34" charset="-122"/>
                 <a:cs typeface="DM Sans" pitchFamily="34" charset="-120"/>
               </a:rPr>
-              <a:t>Income $4,992</a:t>
+              <a:t>Income $4,932</a:t>
             </a:r>
             <a:endParaRPr lang="en-US" sz="1500" dirty="0"/>
           </a:p>
@@ -17197,8 +17197,8 @@
         </p:nvSpPr>
         <p:spPr>
           <a:xfrm>
-            <a:off x="5348969" y="2587752"/>
-            <a:ext cx="1330288" cy="384048"/>
+            <a:off x="5349651" y="2587752"/>
+            <a:ext cx="1372499" cy="384048"/>
           </a:xfrm>
           <a:prstGeom prst="rect">
             <a:avLst/>
@@ -17222,8 +17222,8 @@
         </p:nvSpPr>
         <p:spPr>
           <a:xfrm>
-            <a:off x="5348969" y="2587752"/>
-            <a:ext cx="1330288" cy="384048"/>
+            <a:off x="5349651" y="2587752"/>
+            <a:ext cx="1372499" cy="384048"/>
           </a:xfrm>
           <a:prstGeom prst="rect">
             <a:avLst/>
@@ -17262,7 +17262,7 @@
         <p:spPr>
           <a:xfrm>
             <a:off x="3246120" y="3044952"/>
-            <a:ext cx="3433137" cy="384048"/>
+            <a:ext cx="3476030" cy="384048"/>
           </a:xfrm>
           <a:prstGeom prst="rect">
             <a:avLst/>
@@ -17389,7 +17389,7 @@
                 <a:ea typeface="DM Sans" pitchFamily="34" charset="-122"/>
                 <a:cs typeface="DM Sans" pitchFamily="34" charset="-120"/>
               </a:rPr>
-              <a:t>Donor covers the $3,158 gap</a:t>
+              <a:t>Donor covers the $3,218 gap</a:t>
             </a:r>
             <a:endParaRPr lang="en-US" sz="1300" dirty="0"/>
           </a:p>
@@ -17482,7 +17482,7 @@
         <p:spPr>
           <a:xfrm>
             <a:off x="3246120" y="3831336"/>
-            <a:ext cx="3154274" cy="384048"/>
+            <a:ext cx="3155297" cy="384048"/>
           </a:xfrm>
           <a:prstGeom prst="rect">
             <a:avLst/>
@@ -17531,7 +17531,7 @@
                 <a:ea typeface="DM Sans" pitchFamily="34" charset="-122"/>
                 <a:cs typeface="DM Sans" pitchFamily="34" charset="-120"/>
               </a:rPr>
-              <a:t>Income $7,488</a:t>
+              <a:t>Income $7,398</a:t>
             </a:r>
             <a:endParaRPr lang="en-US" sz="1500" dirty="0"/>
           </a:p>
@@ -17545,8 +17545,8 @@
         </p:nvSpPr>
         <p:spPr>
           <a:xfrm>
-            <a:off x="6400394" y="3831336"/>
-            <a:ext cx="354687" cy="384048"/>
+            <a:off x="6401417" y="3831336"/>
+            <a:ext cx="397504" cy="384048"/>
           </a:xfrm>
           <a:prstGeom prst="rect">
             <a:avLst/>
@@ -17571,7 +17571,7 @@
         <p:spPr>
           <a:xfrm>
             <a:off x="3246120" y="4288536"/>
-            <a:ext cx="3508961" cy="384048"/>
+            <a:ext cx="3552801" cy="384048"/>
           </a:xfrm>
           <a:prstGeom prst="rect">
             <a:avLst/>
@@ -17698,7 +17698,7 @@
                 <a:ea typeface="DM Sans" pitchFamily="34" charset="-122"/>
                 <a:cs typeface="DM Sans" pitchFamily="34" charset="-120"/>
               </a:rPr>
-              <a:t>Donor covers the $842 gap</a:t>
+              <a:t>Donor covers the $932 gap</a:t>
             </a:r>
             <a:endParaRPr lang="en-US" sz="1300" dirty="0"/>
           </a:p>
@@ -17840,7 +17840,7 @@
                 <a:ea typeface="DM Sans" pitchFamily="34" charset="-122"/>
                 <a:cs typeface="DM Sans" pitchFamily="34" charset="-120"/>
               </a:rPr>
-              <a:t>Income $12,156</a:t>
+              <a:t>Income $12,006</a:t>
             </a:r>
             <a:endParaRPr lang="en-US" sz="1500" dirty="0"/>
           </a:p>
@@ -17855,7 +17855,7 @@
         <p:spPr>
           <a:xfrm>
             <a:off x="3246120" y="5532120"/>
-            <a:ext cx="4933608" cy="384048"/>
+            <a:ext cx="4995247" cy="384048"/>
           </a:xfrm>
           <a:prstGeom prst="rect">
             <a:avLst/>
@@ -17943,7 +17943,7 @@
                 <a:ea typeface="DM Serif Text" pitchFamily="34" charset="-122"/>
                 <a:cs typeface="DM Serif Text" pitchFamily="34" charset="-120"/>
               </a:rPr>
-              <a:t>+$444</a:t>
+              <a:t>+$294</a:t>
             </a:r>
             <a:endParaRPr lang="en-US" sz="3000" dirty="0"/>
           </a:p>

</xml_diff>